<commit_message>
main() starts blank in the Colab cell
Students now type all of main(): the loadImage/makeImage setup, the two
pointers, the five CUDA steps, saveImage, the frees and return 0. Only
the kernel signature and the include are given. The four file-I/O
helpers still live in lab/gpulab.h, but the calls to them are typed.

The cell has two markers - the kernel body and the whole of main() -
and run() refuses to compile while either is present. verify.py checks
that main() is genuinely empty apart from its marker.

The solutions are laid out in labelled blocks (setup, STEP 1-5) so the
STEP slides, which pull their code from the solutions, now carry the
setup lines on STEP 1 and saveImage / freeImage / return 0 on STEPs 4
and 5. Nothing appears on a slide that isn't typed, and nothing is
typed that isn't on a slide.
</commit_message>
<xml_diff>
--- a/slides/step-slides.pptx
+++ b/slides/step-slides.pptx
@@ -2703,7 +2703,7 @@
         <p:spPr>
           <a:xfrm>
             <a:off x="777240" y="1783080"/>
-            <a:ext cx="6537960" cy="2011680"/>
+            <a:ext cx="6537960" cy="2286000"/>
           </a:xfrm>
           <a:prstGeom prst="rect">
             <a:avLst/>
@@ -2728,7 +2728,7 @@
         <p:spPr>
           <a:xfrm>
             <a:off x="978408" y="1947672"/>
-            <a:ext cx="6135624" cy="1682496"/>
+            <a:ext cx="6135624" cy="1956816"/>
           </a:xfrm>
           <a:prstGeom prst="rect">
             <a:avLst/>
@@ -2740,6 +2740,76 @@
           <a:bodyPr wrap="square" lIns="0" tIns="0" rIns="0" bIns="0" rtlCol="0" anchor="t"/>
           <a:lstStyle/>
           <a:p>
+            <a:pPr indent="0" marL="0">
+              <a:lnSpc>
+                <a:spcPct val="112000"/>
+              </a:lnSpc>
+              <a:buNone/>
+            </a:pPr>
+            <a:r>
+              <a:rPr lang="en-US" sz="1300" dirty="0">
+                <a:solidFill>
+                  <a:srgbClr val="ECEEF2"/>
+                </a:solidFill>
+                <a:latin typeface="Courier New" pitchFamily="34" charset="0"/>
+                <a:ea typeface="Courier New" pitchFamily="34" charset="-122"/>
+                <a:cs typeface="Courier New" pitchFamily="34" charset="-120"/>
+              </a:rPr>
+              <a:t>Image img = loadImage();</a:t>
+            </a:r>
+            <a:pPr indent="0" marL="0">
+              <a:lnSpc>
+                <a:spcPct val="112000"/>
+              </a:lnSpc>
+              <a:buNone/>
+            </a:pPr>
+            <a:r>
+              <a:rPr lang="en-US" sz="1300" dirty="0">
+                <a:solidFill>
+                  <a:srgbClr val="000000"/>
+                </a:solidFill>
+                <a:latin typeface="Courier New" pitchFamily="34" charset="0"/>
+                <a:ea typeface="Courier New" pitchFamily="34" charset="-122"/>
+                <a:cs typeface="Courier New" pitchFamily="34" charset="-120"/>
+              </a:rPr>
+              <a:t>
+</a:t>
+            </a:r>
+            <a:pPr indent="0" marL="0">
+              <a:lnSpc>
+                <a:spcPct val="112000"/>
+              </a:lnSpc>
+              <a:buNone/>
+            </a:pPr>
+            <a:r>
+              <a:rPr lang="en-US" sz="1300" dirty="0">
+                <a:solidFill>
+                  <a:srgbClr val="ECEEF2"/>
+                </a:solidFill>
+                <a:latin typeface="Courier New" pitchFamily="34" charset="0"/>
+                <a:ea typeface="Courier New" pitchFamily="34" charset="-122"/>
+                <a:cs typeface="Courier New" pitchFamily="34" charset="-120"/>
+              </a:rPr>
+              <a:t>Image out = makeImage(img.w, img.h);</a:t>
+            </a:r>
+            <a:pPr indent="0" marL="0">
+              <a:lnSpc>
+                <a:spcPct val="112000"/>
+              </a:lnSpc>
+              <a:buNone/>
+            </a:pPr>
+            <a:r>
+              <a:rPr lang="en-US" sz="1300" dirty="0">
+                <a:solidFill>
+                  <a:srgbClr val="000000"/>
+                </a:solidFill>
+                <a:latin typeface="Courier New" pitchFamily="34" charset="0"/>
+                <a:ea typeface="Courier New" pitchFamily="34" charset="-122"/>
+                <a:cs typeface="Courier New" pitchFamily="34" charset="-120"/>
+              </a:rPr>
+              <a:t>
+</a:t>
+            </a:r>
             <a:pPr indent="0" marL="0">
               <a:lnSpc>
                 <a:spcPct val="112000"/>
@@ -2967,6 +3037,29 @@
         <p:txBody>
           <a:bodyPr wrap="square" lIns="0" tIns="0" rIns="0" bIns="0" rtlCol="0" anchor="t"/>
           <a:lstStyle/>
+          <a:p>
+            <a:pPr indent="0" marL="0">
+              <a:lnSpc>
+                <a:spcPct val="115000"/>
+              </a:lnSpc>
+              <a:spcAft>
+                <a:spcPts val="500"/>
+              </a:spcAft>
+              <a:buNone/>
+            </a:pPr>
+            <a:r>
+              <a:rPr lang="en-US" sz="1450" dirty="0">
+                <a:solidFill>
+                  <a:srgbClr val="ECEEF2"/>
+                </a:solidFill>
+                <a:latin typeface="Arial" pitchFamily="34" charset="0"/>
+                <a:ea typeface="Arial" pitchFamily="34" charset="-122"/>
+                <a:cs typeface="Arial" pitchFamily="34" charset="-120"/>
+              </a:rPr>
+              <a:t>loadImage / makeImage — the photo into CPU memory, and an empty picture the same size. Helpers from lab/gpulab.h, not CUDA.</a:t>
+            </a:r>
+            <a:endParaRPr lang="en-US" sz="1450" dirty="0"/>
+          </a:p>
           <a:p>
             <a:pPr indent="0" marL="0">
               <a:lnSpc>
@@ -4456,7 +4549,7 @@
                 <a:ea typeface="Courier New" pitchFamily="34" charset="-122"/>
                 <a:cs typeface="Courier New" pitchFamily="34" charset="-120"/>
               </a:rPr>
-              <a:t>("imageKernel");     // given</a:t>
+              <a:t>("imageKernel");</a:t>
             </a:r>
             <a:endParaRPr lang="en-US" sz="1250" dirty="0"/>
           </a:p>
@@ -6411,42 +6504,7 @@
                 <a:ea typeface="Courier New" pitchFamily="34" charset="-122"/>
                 <a:cs typeface="Courier New" pitchFamily="34" charset="-120"/>
               </a:rPr>
-              <a:t>saveImage(out, "build/out.ppm");          // given</a:t>
-            </a:r>
-            <a:pPr indent="0" marL="0">
-              <a:lnSpc>
-                <a:spcPct val="112000"/>
-              </a:lnSpc>
-              <a:buNone/>
-            </a:pPr>
-            <a:r>
-              <a:rPr lang="en-US" sz="1300" dirty="0">
-                <a:solidFill>
-                  <a:srgbClr val="000000"/>
-                </a:solidFill>
-                <a:latin typeface="Courier New" pitchFamily="34" charset="0"/>
-                <a:ea typeface="Courier New" pitchFamily="34" charset="-122"/>
-                <a:cs typeface="Courier New" pitchFamily="34" charset="-120"/>
-              </a:rPr>
-              <a:t>
-</a:t>
-            </a:r>
-            <a:pPr indent="0" marL="0">
-              <a:lnSpc>
-                <a:spcPct val="112000"/>
-              </a:lnSpc>
-              <a:buNone/>
-            </a:pPr>
-            <a:r>
-              <a:rPr lang="en-US" sz="1300" dirty="0">
-                <a:solidFill>
-                  <a:srgbClr val="ECEEF2"/>
-                </a:solidFill>
-                <a:latin typeface="Courier New" pitchFamily="34" charset="0"/>
-                <a:ea typeface="Courier New" pitchFamily="34" charset="-122"/>
-                <a:cs typeface="Courier New" pitchFamily="34" charset="-120"/>
-              </a:rPr>
-              <a:t>saveImage(out, "build/out.ppm");   // given</a:t>
+              <a:t>saveImage(out, "build/out.ppm");</a:t>
             </a:r>
             <a:endParaRPr lang="en-US" sz="1300" dirty="0"/>
           </a:p>
@@ -7046,7 +7104,7 @@
         <p:spPr>
           <a:xfrm>
             <a:off x="777240" y="1783080"/>
-            <a:ext cx="6537960" cy="1508760"/>
+            <a:ext cx="6537960" cy="1737360"/>
           </a:xfrm>
           <a:prstGeom prst="rect">
             <a:avLst/>
@@ -7071,7 +7129,7 @@
         <p:spPr>
           <a:xfrm>
             <a:off x="978408" y="1947672"/>
-            <a:ext cx="6135624" cy="1179576"/>
+            <a:ext cx="6135624" cy="1408176"/>
           </a:xfrm>
           <a:prstGeom prst="rect">
             <a:avLst/>
@@ -7092,23 +7150,6 @@
             <a:r>
               <a:rPr lang="en-US" sz="1300" dirty="0">
                 <a:solidFill>
-                  <a:srgbClr val="ECEEF2"/>
-                </a:solidFill>
-                <a:latin typeface="Courier New" pitchFamily="34" charset="0"/>
-                <a:ea typeface="Courier New" pitchFamily="34" charset="-122"/>
-                <a:cs typeface="Courier New" pitchFamily="34" charset="-120"/>
-              </a:rPr>
-              <a:t>    </a:t>
-            </a:r>
-            <a:pPr indent="0" marL="0">
-              <a:lnSpc>
-                <a:spcPct val="112000"/>
-              </a:lnSpc>
-              <a:buNone/>
-            </a:pPr>
-            <a:r>
-              <a:rPr lang="en-US" sz="1300" dirty="0">
-                <a:solidFill>
                   <a:srgbClr val="46D07E"/>
                 </a:solidFill>
                 <a:latin typeface="Courier New" pitchFamily="34" charset="0"/>
@@ -7161,23 +7202,6 @@
             <a:r>
               <a:rPr lang="en-US" sz="1300" dirty="0">
                 <a:solidFill>
-                  <a:srgbClr val="ECEEF2"/>
-                </a:solidFill>
-                <a:latin typeface="Courier New" pitchFamily="34" charset="0"/>
-                <a:ea typeface="Courier New" pitchFamily="34" charset="-122"/>
-                <a:cs typeface="Courier New" pitchFamily="34" charset="-120"/>
-              </a:rPr>
-              <a:t>    </a:t>
-            </a:r>
-            <a:pPr indent="0" marL="0">
-              <a:lnSpc>
-                <a:spcPct val="112000"/>
-              </a:lnSpc>
-              <a:buNone/>
-            </a:pPr>
-            <a:r>
-              <a:rPr lang="en-US" sz="1300" dirty="0">
-                <a:solidFill>
                   <a:srgbClr val="46D07E"/>
                 </a:solidFill>
                 <a:latin typeface="Courier New" pitchFamily="34" charset="0"/>
@@ -7236,7 +7260,7 @@
                 <a:ea typeface="Courier New" pitchFamily="34" charset="-122"/>
                 <a:cs typeface="Courier New" pitchFamily="34" charset="-120"/>
               </a:rPr>
-              <a:t>    freeImage(img);                           // given</a:t>
+              <a:t>freeImage(img);</a:t>
             </a:r>
             <a:pPr indent="0" marL="0">
               <a:lnSpc>
@@ -7271,7 +7295,7 @@
                 <a:ea typeface="Courier New" pitchFamily="34" charset="-122"/>
                 <a:cs typeface="Courier New" pitchFamily="34" charset="-120"/>
               </a:rPr>
-              <a:t>    freeImage(out);</a:t>
+              <a:t>freeImage(out);</a:t>
             </a:r>
             <a:pPr indent="0" marL="0">
               <a:lnSpc>
@@ -7306,112 +7330,7 @@
                 <a:ea typeface="Courier New" pitchFamily="34" charset="-122"/>
                 <a:cs typeface="Courier New" pitchFamily="34" charset="-120"/>
               </a:rPr>
-              <a:t>    return 0;</a:t>
-            </a:r>
-            <a:pPr indent="0" marL="0">
-              <a:lnSpc>
-                <a:spcPct val="112000"/>
-              </a:lnSpc>
-              <a:buNone/>
-            </a:pPr>
-            <a:r>
-              <a:rPr lang="en-US" sz="1300" dirty="0">
-                <a:solidFill>
-                  <a:srgbClr val="000000"/>
-                </a:solidFill>
-                <a:latin typeface="Courier New" pitchFamily="34" charset="0"/>
-                <a:ea typeface="Courier New" pitchFamily="34" charset="-122"/>
-                <a:cs typeface="Courier New" pitchFamily="34" charset="-120"/>
-              </a:rPr>
-              <a:t>
-</a:t>
-            </a:r>
-            <a:pPr indent="0" marL="0">
-              <a:lnSpc>
-                <a:spcPct val="112000"/>
-              </a:lnSpc>
-              <a:buNone/>
-            </a:pPr>
-            <a:r>
-              <a:rPr lang="en-US" sz="1300" dirty="0">
-                <a:solidFill>
-                  <a:srgbClr val="ECEEF2"/>
-                </a:solidFill>
-                <a:latin typeface="Courier New" pitchFamily="34" charset="0"/>
-                <a:ea typeface="Courier New" pitchFamily="34" charset="-122"/>
-                <a:cs typeface="Courier New" pitchFamily="34" charset="-120"/>
-              </a:rPr>
-              <a:t>}</a:t>
-            </a:r>
-            <a:pPr indent="0" marL="0">
-              <a:lnSpc>
-                <a:spcPct val="112000"/>
-              </a:lnSpc>
-              <a:buNone/>
-            </a:pPr>
-            <a:r>
-              <a:rPr lang="en-US" sz="1300" dirty="0">
-                <a:solidFill>
-                  <a:srgbClr val="000000"/>
-                </a:solidFill>
-                <a:latin typeface="Courier New" pitchFamily="34" charset="0"/>
-                <a:ea typeface="Courier New" pitchFamily="34" charset="-122"/>
-                <a:cs typeface="Courier New" pitchFamily="34" charset="-120"/>
-              </a:rPr>
-              <a:t>
-</a:t>
-            </a:r>
-            <a:pPr indent="0" marL="0">
-              <a:lnSpc>
-                <a:spcPct val="112000"/>
-              </a:lnSpc>
-              <a:buNone/>
-            </a:pPr>
-            <a:r>
-              <a:rPr lang="en-US" sz="1300" dirty="0">
-                <a:solidFill>
-                  <a:srgbClr val="ECEEF2"/>
-                </a:solidFill>
-                <a:latin typeface="Courier New" pitchFamily="34" charset="0"/>
-                <a:ea typeface="Courier New" pitchFamily="34" charset="-122"/>
-                <a:cs typeface="Courier New" pitchFamily="34" charset="-120"/>
-              </a:rPr>
-              <a:t>freeImage(img);                   // given</a:t>
-            </a:r>
-            <a:pPr indent="0" marL="0">
-              <a:lnSpc>
-                <a:spcPct val="112000"/>
-              </a:lnSpc>
-              <a:buNone/>
-            </a:pPr>
-            <a:r>
-              <a:rPr lang="en-US" sz="1300" dirty="0">
-                <a:solidFill>
-                  <a:srgbClr val="000000"/>
-                </a:solidFill>
-                <a:latin typeface="Courier New" pitchFamily="34" charset="0"/>
-                <a:ea typeface="Courier New" pitchFamily="34" charset="-122"/>
-                <a:cs typeface="Courier New" pitchFamily="34" charset="-120"/>
-              </a:rPr>
-              <a:t>
-</a:t>
-            </a:r>
-            <a:pPr indent="0" marL="0">
-              <a:lnSpc>
-                <a:spcPct val="112000"/>
-              </a:lnSpc>
-              <a:buNone/>
-            </a:pPr>
-            <a:r>
-              <a:rPr lang="en-US" sz="1300" dirty="0">
-                <a:solidFill>
-                  <a:srgbClr val="ECEEF2"/>
-                </a:solidFill>
-                <a:latin typeface="Courier New" pitchFamily="34" charset="0"/>
-                <a:ea typeface="Courier New" pitchFamily="34" charset="-122"/>
-                <a:cs typeface="Courier New" pitchFamily="34" charset="-120"/>
-              </a:rPr>
-              <a:t>freeImage(out);                   // given</a:t>
+              <a:t>return 0;</a:t>
             </a:r>
             <a:endParaRPr lang="en-US" sz="1300" dirty="0"/>
           </a:p>
@@ -7543,7 +7462,7 @@
                 <a:ea typeface="Arial" pitchFamily="34" charset="-122"/>
                 <a:cs typeface="Arial" pitchFamily="34" charset="-120"/>
               </a:rPr>
-              <a:t>The two freeImage lines are the CPU side — given, not CUDA.</a:t>
+              <a:t>freeImage is the CPU side — the helper, not CUDA. Then return 0.</a:t>
             </a:r>
             <a:endParaRPr lang="en-US" sz="1400" dirty="0"/>
           </a:p>

</xml_diff>

<commit_message>
Blur is its own cell with main() pre-filled; only the kernel is typed
Build 2 is now student/blur.cu, a second cell whose main() is already
written - the same five steps as Build 1 with the kernel renamed to
blurKernel. The only thing typed in that file is the kernel, copied
whole from its slide. Build 1 is unchanged: main() empty, kernel body
empty, everything typed.

lab.run("blur") checks the second file. The checker now takes the
expected result, so a greyscale kernel pasted into the blur file is
called out as "greyscale, not blurred" instead of passing as a correct
greyscale. verify.py also asserts the pre-filled main() in the shipped
cell is identical to the finished version's, so the two can't drift.

The Build 2 slide now shows the entire blurKernel function, since that
is what gets copied.
</commit_message>
<xml_diff>
--- a/slides/step-slides.pptx
+++ b/slides/step-slides.pptx
@@ -1155,11 +1155,15 @@
           <a:p>
             <a:r>
               <a:rPr lang="en-US" dirty="0"/>
-              <a:t>Scroll to main() first and say 'nothing down here changes'. That's the lesson.
-Concept: the host code is a reusable shell. Only what one thread does is different.
+              <a:t>This whole function gets typed into student/blur.cu, above the main() that is
+already written there. Open the cell first and scroll through main(): 'you typed
+exactly this twenty minutes ago - only the kernel's name is different.'
+Concept: the host code is a reusable shell. What the GPU DOES lives in the kernel.
 Expected: '✅ Blur, and it matches a CPU version exactly - edges included.'
 Pause: on 'divide by n'. Ask why not 49. Someone will get it - corners.
-Stumble: /49 - the check says 'the outermost 3 pixels are dark'. Or forgetting the #define - won't compile, names BLUR_SIZE.
+Stumble: /49 - the check says 'the outermost 3 pixels are dark'. A greyscale kernel
+pasted here by mistake - the check says 'greyscale, not blurred'. Wrong function name -
+won't compile; main() calls blurKernel.
 Then: BLUR_SIZE 15, re-run. Twenty times the work, same instant.</a:t>
             </a:r>
             <a:endParaRPr lang="en-US" dirty="0"/>
@@ -2378,8 +2382,8 @@
         </p:nvSpPr>
         <p:spPr>
           <a:xfrm>
-            <a:off x="5928055" y="6556248"/>
-            <a:ext cx="5486400" cy="228600"/>
+            <a:off x="5928055" y="6620256"/>
+            <a:ext cx="5486400" cy="201168"/>
           </a:xfrm>
           <a:prstGeom prst="rect">
             <a:avLst/>
@@ -3245,8 +3249,8 @@
         </p:nvSpPr>
         <p:spPr>
           <a:xfrm>
-            <a:off x="5928055" y="6556248"/>
-            <a:ext cx="5486400" cy="228600"/>
+            <a:off x="5928055" y="6620256"/>
+            <a:ext cx="5486400" cy="201168"/>
           </a:xfrm>
           <a:prstGeom prst="rect">
             <a:avLst/>
@@ -3948,8 +3952,8 @@
         </p:nvSpPr>
         <p:spPr>
           <a:xfrm>
-            <a:off x="5928055" y="6556248"/>
-            <a:ext cx="5486400" cy="228600"/>
+            <a:off x="5928055" y="6620256"/>
+            <a:ext cx="5486400" cy="201168"/>
           </a:xfrm>
           <a:prstGeom prst="rect">
             <a:avLst/>
@@ -4847,8 +4851,8 @@
         </p:nvSpPr>
         <p:spPr>
           <a:xfrm>
-            <a:off x="5928055" y="6556248"/>
-            <a:ext cx="5486400" cy="228600"/>
+            <a:off x="5928055" y="6620256"/>
+            <a:ext cx="5486400" cy="201168"/>
           </a:xfrm>
           <a:prstGeom prst="rect">
             <a:avLst/>
@@ -6041,8 +6045,8 @@
         </p:nvSpPr>
         <p:spPr>
           <a:xfrm>
-            <a:off x="5928055" y="6556248"/>
-            <a:ext cx="5486400" cy="228600"/>
+            <a:off x="5928055" y="6620256"/>
+            <a:ext cx="5486400" cy="201168"/>
           </a:xfrm>
           <a:prstGeom prst="rect">
             <a:avLst/>
@@ -6779,8 +6783,8 @@
         </p:nvSpPr>
         <p:spPr>
           <a:xfrm>
-            <a:off x="5928055" y="6556248"/>
-            <a:ext cx="5486400" cy="228600"/>
+            <a:off x="5928055" y="6620256"/>
+            <a:ext cx="5486400" cy="201168"/>
           </a:xfrm>
           <a:prstGeom prst="rect">
             <a:avLst/>
@@ -7540,8 +7544,8 @@
         </p:nvSpPr>
         <p:spPr>
           <a:xfrm>
-            <a:off x="5928055" y="6556248"/>
-            <a:ext cx="5486400" cy="228600"/>
+            <a:off x="5928055" y="6620256"/>
+            <a:ext cx="5486400" cy="201168"/>
           </a:xfrm>
           <a:prstGeom prst="rect">
             <a:avLst/>
@@ -7811,7 +7815,7 @@
                 <a:ea typeface="Courier New" pitchFamily="34" charset="-122"/>
                 <a:cs typeface="Courier New" pitchFamily="34" charset="-120"/>
               </a:rPr>
-              <a:t>BUILD 2 · STEP 3 AGAIN</a:t>
+              <a:t>BUILD 2 · THE KERNEL</a:t>
             </a:r>
             <a:endParaRPr lang="en-US" sz="1300" dirty="0"/>
           </a:p>
@@ -7850,7 +7854,7 @@
                 <a:ea typeface="Arial" pitchFamily="34" charset="-122"/>
                 <a:cs typeface="Arial" pitchFamily="34" charset="-120"/>
               </a:rPr>
-              <a:t>Same file. Change only the kernel.</a:t>
+              <a:t>New file, same main(). Copy this function.</a:t>
             </a:r>
             <a:endParaRPr lang="en-US" sz="3400" dirty="0"/>
           </a:p>
@@ -7865,7 +7869,7 @@
         <p:spPr>
           <a:xfrm>
             <a:off x="777240" y="1783080"/>
-            <a:ext cx="7223760" cy="3977640"/>
+            <a:ext cx="7498080" cy="4114800"/>
           </a:xfrm>
           <a:prstGeom prst="rect">
             <a:avLst/>
@@ -7890,7 +7894,7 @@
         <p:spPr>
           <a:xfrm>
             <a:off x="978408" y="1947672"/>
-            <a:ext cx="6821424" cy="3648456"/>
+            <a:ext cx="7095744" cy="3785616"/>
           </a:xfrm>
           <a:prstGeom prst="rect">
             <a:avLst/>
@@ -7909,24 +7913,7 @@
               <a:buNone/>
             </a:pPr>
             <a:r>
-              <a:rPr lang="en-US" sz="1050" dirty="0">
-                <a:solidFill>
-                  <a:srgbClr val="ECEEF2"/>
-                </a:solidFill>
-                <a:latin typeface="Courier New" pitchFamily="34" charset="0"/>
-                <a:ea typeface="Courier New" pitchFamily="34" charset="-122"/>
-                <a:cs typeface="Courier New" pitchFamily="34" charset="-120"/>
-              </a:rPr>
-              <a:t>#define </a:t>
-            </a:r>
-            <a:pPr indent="0" marL="0">
-              <a:lnSpc>
-                <a:spcPct val="112000"/>
-              </a:lnSpc>
-              <a:buNone/>
-            </a:pPr>
-            <a:r>
-              <a:rPr lang="en-US" sz="1050" dirty="0">
+              <a:rPr lang="en-US" sz="920" dirty="0">
                 <a:solidFill>
                   <a:srgbClr val="46D07E"/>
                 </a:solidFill>
@@ -7934,33 +7921,33 @@
                 <a:ea typeface="Courier New" pitchFamily="34" charset="-122"/>
                 <a:cs typeface="Courier New" pitchFamily="34" charset="-120"/>
               </a:rPr>
-              <a:t>BLUR_SIZE</a:t>
-            </a:r>
-            <a:pPr indent="0" marL="0">
-              <a:lnSpc>
-                <a:spcPct val="112000"/>
-              </a:lnSpc>
-              <a:buNone/>
-            </a:pPr>
-            <a:r>
-              <a:rPr lang="en-US" sz="1050" dirty="0">
-                <a:solidFill>
-                  <a:srgbClr val="ECEEF2"/>
-                </a:solidFill>
-                <a:latin typeface="Courier New" pitchFamily="34" charset="0"/>
-                <a:ea typeface="Courier New" pitchFamily="34" charset="-122"/>
-                <a:cs typeface="Courier New" pitchFamily="34" charset="-120"/>
-              </a:rPr>
-              <a:t> 3          // under the #include, at the top</a:t>
-            </a:r>
-            <a:pPr indent="0" marL="0">
-              <a:lnSpc>
-                <a:spcPct val="112000"/>
-              </a:lnSpc>
-              <a:buNone/>
-            </a:pPr>
-            <a:r>
-              <a:rPr lang="en-US" sz="1050" dirty="0">
+              <a:t>__global__</a:t>
+            </a:r>
+            <a:pPr indent="0" marL="0">
+              <a:lnSpc>
+                <a:spcPct val="112000"/>
+              </a:lnSpc>
+              <a:buNone/>
+            </a:pPr>
+            <a:r>
+              <a:rPr lang="en-US" sz="920" dirty="0">
+                <a:solidFill>
+                  <a:srgbClr val="ECEEF2"/>
+                </a:solidFill>
+                <a:latin typeface="Courier New" pitchFamily="34" charset="0"/>
+                <a:ea typeface="Courier New" pitchFamily="34" charset="-122"/>
+                <a:cs typeface="Courier New" pitchFamily="34" charset="-120"/>
+              </a:rPr>
+              <a:t> void blurKernel(unsigned char* out, unsigned char* in, int w, int h) {</a:t>
+            </a:r>
+            <a:pPr indent="0" marL="0">
+              <a:lnSpc>
+                <a:spcPct val="112000"/>
+              </a:lnSpc>
+              <a:buNone/>
+            </a:pPr>
+            <a:r>
+              <a:rPr lang="en-US" sz="920" dirty="0">
                 <a:solidFill>
                   <a:srgbClr val="000000"/>
                 </a:solidFill>
@@ -7978,24 +7965,126 @@
               <a:buNone/>
             </a:pPr>
             <a:r>
-              <a:rPr lang="en-US" sz="1050" dirty="0">
-                <a:solidFill>
-                  <a:srgbClr val="6B7480"/>
-                </a:solidFill>
-                <a:latin typeface="Courier New" pitchFamily="34" charset="0"/>
-                <a:ea typeface="Courier New" pitchFamily="34" charset="-122"/>
-                <a:cs typeface="Courier New" pitchFamily="34" charset="-120"/>
-              </a:rPr>
-              <a:t>// ...then replace everything INSIDE  if (col &lt; w &amp;&amp; row &lt; h) {  with:</a:t>
-            </a:r>
-            <a:pPr indent="0" marL="0">
-              <a:lnSpc>
-                <a:spcPct val="112000"/>
-              </a:lnSpc>
-              <a:buNone/>
-            </a:pPr>
-            <a:r>
-              <a:rPr lang="en-US" sz="1050" dirty="0">
+              <a:rPr lang="en-US" sz="920" dirty="0">
+                <a:solidFill>
+                  <a:srgbClr val="ECEEF2"/>
+                </a:solidFill>
+                <a:latin typeface="Courier New" pitchFamily="34" charset="0"/>
+                <a:ea typeface="Courier New" pitchFamily="34" charset="-122"/>
+                <a:cs typeface="Courier New" pitchFamily="34" charset="-120"/>
+              </a:rPr>
+              <a:t>    int col = </a:t>
+            </a:r>
+            <a:pPr indent="0" marL="0">
+              <a:lnSpc>
+                <a:spcPct val="112000"/>
+              </a:lnSpc>
+              <a:buNone/>
+            </a:pPr>
+            <a:r>
+              <a:rPr lang="en-US" sz="920" dirty="0">
+                <a:solidFill>
+                  <a:srgbClr val="46D07E"/>
+                </a:solidFill>
+                <a:latin typeface="Courier New" pitchFamily="34" charset="0"/>
+                <a:ea typeface="Courier New" pitchFamily="34" charset="-122"/>
+                <a:cs typeface="Courier New" pitchFamily="34" charset="-120"/>
+              </a:rPr>
+              <a:t>blockIdx.x</a:t>
+            </a:r>
+            <a:pPr indent="0" marL="0">
+              <a:lnSpc>
+                <a:spcPct val="112000"/>
+              </a:lnSpc>
+              <a:buNone/>
+            </a:pPr>
+            <a:r>
+              <a:rPr lang="en-US" sz="920" dirty="0">
+                <a:solidFill>
+                  <a:srgbClr val="ECEEF2"/>
+                </a:solidFill>
+                <a:latin typeface="Courier New" pitchFamily="34" charset="0"/>
+                <a:ea typeface="Courier New" pitchFamily="34" charset="-122"/>
+                <a:cs typeface="Courier New" pitchFamily="34" charset="-120"/>
+              </a:rPr>
+              <a:t> * </a:t>
+            </a:r>
+            <a:pPr indent="0" marL="0">
+              <a:lnSpc>
+                <a:spcPct val="112000"/>
+              </a:lnSpc>
+              <a:buNone/>
+            </a:pPr>
+            <a:r>
+              <a:rPr lang="en-US" sz="920" dirty="0">
+                <a:solidFill>
+                  <a:srgbClr val="46D07E"/>
+                </a:solidFill>
+                <a:latin typeface="Courier New" pitchFamily="34" charset="0"/>
+                <a:ea typeface="Courier New" pitchFamily="34" charset="-122"/>
+                <a:cs typeface="Courier New" pitchFamily="34" charset="-120"/>
+              </a:rPr>
+              <a:t>blockDim.x</a:t>
+            </a:r>
+            <a:pPr indent="0" marL="0">
+              <a:lnSpc>
+                <a:spcPct val="112000"/>
+              </a:lnSpc>
+              <a:buNone/>
+            </a:pPr>
+            <a:r>
+              <a:rPr lang="en-US" sz="920" dirty="0">
+                <a:solidFill>
+                  <a:srgbClr val="ECEEF2"/>
+                </a:solidFill>
+                <a:latin typeface="Courier New" pitchFamily="34" charset="0"/>
+                <a:ea typeface="Courier New" pitchFamily="34" charset="-122"/>
+                <a:cs typeface="Courier New" pitchFamily="34" charset="-120"/>
+              </a:rPr>
+              <a:t> + </a:t>
+            </a:r>
+            <a:pPr indent="0" marL="0">
+              <a:lnSpc>
+                <a:spcPct val="112000"/>
+              </a:lnSpc>
+              <a:buNone/>
+            </a:pPr>
+            <a:r>
+              <a:rPr lang="en-US" sz="920" dirty="0">
+                <a:solidFill>
+                  <a:srgbClr val="46D07E"/>
+                </a:solidFill>
+                <a:latin typeface="Courier New" pitchFamily="34" charset="0"/>
+                <a:ea typeface="Courier New" pitchFamily="34" charset="-122"/>
+                <a:cs typeface="Courier New" pitchFamily="34" charset="-120"/>
+              </a:rPr>
+              <a:t>threadIdx.x</a:t>
+            </a:r>
+            <a:pPr indent="0" marL="0">
+              <a:lnSpc>
+                <a:spcPct val="112000"/>
+              </a:lnSpc>
+              <a:buNone/>
+            </a:pPr>
+            <a:r>
+              <a:rPr lang="en-US" sz="920" dirty="0">
+                <a:solidFill>
+                  <a:srgbClr val="ECEEF2"/>
+                </a:solidFill>
+                <a:latin typeface="Courier New" pitchFamily="34" charset="0"/>
+                <a:ea typeface="Courier New" pitchFamily="34" charset="-122"/>
+                <a:cs typeface="Courier New" pitchFamily="34" charset="-120"/>
+              </a:rPr>
+              <a:t>;</a:t>
+            </a:r>
+            <a:pPr indent="0" marL="0">
+              <a:lnSpc>
+                <a:spcPct val="112000"/>
+              </a:lnSpc>
+              <a:buNone/>
+            </a:pPr>
+            <a:r>
+              <a:rPr lang="en-US" sz="920" dirty="0">
                 <a:solidFill>
                   <a:srgbClr val="000000"/>
                 </a:solidFill>
@@ -8013,24 +8102,126 @@
               <a:buNone/>
             </a:pPr>
             <a:r>
-              <a:rPr lang="en-US" sz="1050" dirty="0">
-                <a:solidFill>
-                  <a:srgbClr val="ECEEF2"/>
-                </a:solidFill>
-                <a:latin typeface="Courier New" pitchFamily="34" charset="0"/>
-                <a:ea typeface="Courier New" pitchFamily="34" charset="-122"/>
-                <a:cs typeface="Courier New" pitchFamily="34" charset="-120"/>
-              </a:rPr>
-              <a:t>int r = 0, g = 0, b = 0;</a:t>
-            </a:r>
-            <a:pPr indent="0" marL="0">
-              <a:lnSpc>
-                <a:spcPct val="112000"/>
-              </a:lnSpc>
-              <a:buNone/>
-            </a:pPr>
-            <a:r>
-              <a:rPr lang="en-US" sz="1050" dirty="0">
+              <a:rPr lang="en-US" sz="920" dirty="0">
+                <a:solidFill>
+                  <a:srgbClr val="ECEEF2"/>
+                </a:solidFill>
+                <a:latin typeface="Courier New" pitchFamily="34" charset="0"/>
+                <a:ea typeface="Courier New" pitchFamily="34" charset="-122"/>
+                <a:cs typeface="Courier New" pitchFamily="34" charset="-120"/>
+              </a:rPr>
+              <a:t>    int row = </a:t>
+            </a:r>
+            <a:pPr indent="0" marL="0">
+              <a:lnSpc>
+                <a:spcPct val="112000"/>
+              </a:lnSpc>
+              <a:buNone/>
+            </a:pPr>
+            <a:r>
+              <a:rPr lang="en-US" sz="920" dirty="0">
+                <a:solidFill>
+                  <a:srgbClr val="46D07E"/>
+                </a:solidFill>
+                <a:latin typeface="Courier New" pitchFamily="34" charset="0"/>
+                <a:ea typeface="Courier New" pitchFamily="34" charset="-122"/>
+                <a:cs typeface="Courier New" pitchFamily="34" charset="-120"/>
+              </a:rPr>
+              <a:t>blockIdx.y</a:t>
+            </a:r>
+            <a:pPr indent="0" marL="0">
+              <a:lnSpc>
+                <a:spcPct val="112000"/>
+              </a:lnSpc>
+              <a:buNone/>
+            </a:pPr>
+            <a:r>
+              <a:rPr lang="en-US" sz="920" dirty="0">
+                <a:solidFill>
+                  <a:srgbClr val="ECEEF2"/>
+                </a:solidFill>
+                <a:latin typeface="Courier New" pitchFamily="34" charset="0"/>
+                <a:ea typeface="Courier New" pitchFamily="34" charset="-122"/>
+                <a:cs typeface="Courier New" pitchFamily="34" charset="-120"/>
+              </a:rPr>
+              <a:t> * </a:t>
+            </a:r>
+            <a:pPr indent="0" marL="0">
+              <a:lnSpc>
+                <a:spcPct val="112000"/>
+              </a:lnSpc>
+              <a:buNone/>
+            </a:pPr>
+            <a:r>
+              <a:rPr lang="en-US" sz="920" dirty="0">
+                <a:solidFill>
+                  <a:srgbClr val="46D07E"/>
+                </a:solidFill>
+                <a:latin typeface="Courier New" pitchFamily="34" charset="0"/>
+                <a:ea typeface="Courier New" pitchFamily="34" charset="-122"/>
+                <a:cs typeface="Courier New" pitchFamily="34" charset="-120"/>
+              </a:rPr>
+              <a:t>blockDim.y</a:t>
+            </a:r>
+            <a:pPr indent="0" marL="0">
+              <a:lnSpc>
+                <a:spcPct val="112000"/>
+              </a:lnSpc>
+              <a:buNone/>
+            </a:pPr>
+            <a:r>
+              <a:rPr lang="en-US" sz="920" dirty="0">
+                <a:solidFill>
+                  <a:srgbClr val="ECEEF2"/>
+                </a:solidFill>
+                <a:latin typeface="Courier New" pitchFamily="34" charset="0"/>
+                <a:ea typeface="Courier New" pitchFamily="34" charset="-122"/>
+                <a:cs typeface="Courier New" pitchFamily="34" charset="-120"/>
+              </a:rPr>
+              <a:t> + </a:t>
+            </a:r>
+            <a:pPr indent="0" marL="0">
+              <a:lnSpc>
+                <a:spcPct val="112000"/>
+              </a:lnSpc>
+              <a:buNone/>
+            </a:pPr>
+            <a:r>
+              <a:rPr lang="en-US" sz="920" dirty="0">
+                <a:solidFill>
+                  <a:srgbClr val="46D07E"/>
+                </a:solidFill>
+                <a:latin typeface="Courier New" pitchFamily="34" charset="0"/>
+                <a:ea typeface="Courier New" pitchFamily="34" charset="-122"/>
+                <a:cs typeface="Courier New" pitchFamily="34" charset="-120"/>
+              </a:rPr>
+              <a:t>threadIdx.y</a:t>
+            </a:r>
+            <a:pPr indent="0" marL="0">
+              <a:lnSpc>
+                <a:spcPct val="112000"/>
+              </a:lnSpc>
+              <a:buNone/>
+            </a:pPr>
+            <a:r>
+              <a:rPr lang="en-US" sz="920" dirty="0">
+                <a:solidFill>
+                  <a:srgbClr val="ECEEF2"/>
+                </a:solidFill>
+                <a:latin typeface="Courier New" pitchFamily="34" charset="0"/>
+                <a:ea typeface="Courier New" pitchFamily="34" charset="-122"/>
+                <a:cs typeface="Courier New" pitchFamily="34" charset="-120"/>
+              </a:rPr>
+              <a:t>;</a:t>
+            </a:r>
+            <a:pPr indent="0" marL="0">
+              <a:lnSpc>
+                <a:spcPct val="112000"/>
+              </a:lnSpc>
+              <a:buNone/>
+            </a:pPr>
+            <a:r>
+              <a:rPr lang="en-US" sz="920" dirty="0">
                 <a:solidFill>
                   <a:srgbClr val="000000"/>
                 </a:solidFill>
@@ -8048,24 +8239,24 @@
               <a:buNone/>
             </a:pPr>
             <a:r>
-              <a:rPr lang="en-US" sz="1050" dirty="0">
-                <a:solidFill>
-                  <a:srgbClr val="ECEEF2"/>
-                </a:solidFill>
-                <a:latin typeface="Courier New" pitchFamily="34" charset="0"/>
-                <a:ea typeface="Courier New" pitchFamily="34" charset="-122"/>
-                <a:cs typeface="Courier New" pitchFamily="34" charset="-120"/>
-              </a:rPr>
-              <a:t>int n = 0;</a:t>
-            </a:r>
-            <a:pPr indent="0" marL="0">
-              <a:lnSpc>
-                <a:spcPct val="112000"/>
-              </a:lnSpc>
-              <a:buNone/>
-            </a:pPr>
-            <a:r>
-              <a:rPr lang="en-US" sz="1050" dirty="0">
+              <a:rPr lang="en-US" sz="920" dirty="0">
+                <a:solidFill>
+                  <a:srgbClr val="ECEEF2"/>
+                </a:solidFill>
+                <a:latin typeface="Courier New" pitchFamily="34" charset="0"/>
+                <a:ea typeface="Courier New" pitchFamily="34" charset="-122"/>
+                <a:cs typeface="Courier New" pitchFamily="34" charset="-120"/>
+              </a:rPr>
+              <a:t>    if (col &lt; w &amp;&amp; row &lt; h) {</a:t>
+            </a:r>
+            <a:pPr indent="0" marL="0">
+              <a:lnSpc>
+                <a:spcPct val="112000"/>
+              </a:lnSpc>
+              <a:buNone/>
+            </a:pPr>
+            <a:r>
+              <a:rPr lang="en-US" sz="920" dirty="0">
                 <a:solidFill>
                   <a:srgbClr val="000000"/>
                 </a:solidFill>
@@ -8083,92 +8274,24 @@
               <a:buNone/>
             </a:pPr>
             <a:r>
-              <a:rPr lang="en-US" sz="1050" dirty="0">
-                <a:solidFill>
-                  <a:srgbClr val="ECEEF2"/>
-                </a:solidFill>
-                <a:latin typeface="Courier New" pitchFamily="34" charset="0"/>
-                <a:ea typeface="Courier New" pitchFamily="34" charset="-122"/>
-                <a:cs typeface="Courier New" pitchFamily="34" charset="-120"/>
-              </a:rPr>
-              <a:t>for (int dr = -</a:t>
-            </a:r>
-            <a:pPr indent="0" marL="0">
-              <a:lnSpc>
-                <a:spcPct val="112000"/>
-              </a:lnSpc>
-              <a:buNone/>
-            </a:pPr>
-            <a:r>
-              <a:rPr lang="en-US" sz="1050" dirty="0">
-                <a:solidFill>
-                  <a:srgbClr val="46D07E"/>
-                </a:solidFill>
-                <a:latin typeface="Courier New" pitchFamily="34" charset="0"/>
-                <a:ea typeface="Courier New" pitchFamily="34" charset="-122"/>
-                <a:cs typeface="Courier New" pitchFamily="34" charset="-120"/>
-              </a:rPr>
-              <a:t>BLUR_SIZE</a:t>
-            </a:r>
-            <a:pPr indent="0" marL="0">
-              <a:lnSpc>
-                <a:spcPct val="112000"/>
-              </a:lnSpc>
-              <a:buNone/>
-            </a:pPr>
-            <a:r>
-              <a:rPr lang="en-US" sz="1050" dirty="0">
-                <a:solidFill>
-                  <a:srgbClr val="ECEEF2"/>
-                </a:solidFill>
-                <a:latin typeface="Courier New" pitchFamily="34" charset="0"/>
-                <a:ea typeface="Courier New" pitchFamily="34" charset="-122"/>
-                <a:cs typeface="Courier New" pitchFamily="34" charset="-120"/>
-              </a:rPr>
-              <a:t>; dr &lt;= </a:t>
-            </a:r>
-            <a:pPr indent="0" marL="0">
-              <a:lnSpc>
-                <a:spcPct val="112000"/>
-              </a:lnSpc>
-              <a:buNone/>
-            </a:pPr>
-            <a:r>
-              <a:rPr lang="en-US" sz="1050" dirty="0">
-                <a:solidFill>
-                  <a:srgbClr val="46D07E"/>
-                </a:solidFill>
-                <a:latin typeface="Courier New" pitchFamily="34" charset="0"/>
-                <a:ea typeface="Courier New" pitchFamily="34" charset="-122"/>
-                <a:cs typeface="Courier New" pitchFamily="34" charset="-120"/>
-              </a:rPr>
-              <a:t>BLUR_SIZE</a:t>
-            </a:r>
-            <a:pPr indent="0" marL="0">
-              <a:lnSpc>
-                <a:spcPct val="112000"/>
-              </a:lnSpc>
-              <a:buNone/>
-            </a:pPr>
-            <a:r>
-              <a:rPr lang="en-US" sz="1050" dirty="0">
-                <a:solidFill>
-                  <a:srgbClr val="ECEEF2"/>
-                </a:solidFill>
-                <a:latin typeface="Courier New" pitchFamily="34" charset="0"/>
-                <a:ea typeface="Courier New" pitchFamily="34" charset="-122"/>
-                <a:cs typeface="Courier New" pitchFamily="34" charset="-120"/>
-              </a:rPr>
-              <a:t>; ++dr) {</a:t>
-            </a:r>
-            <a:pPr indent="0" marL="0">
-              <a:lnSpc>
-                <a:spcPct val="112000"/>
-              </a:lnSpc>
-              <a:buNone/>
-            </a:pPr>
-            <a:r>
-              <a:rPr lang="en-US" sz="1050" dirty="0">
+              <a:rPr lang="en-US" sz="920" dirty="0">
+                <a:solidFill>
+                  <a:srgbClr val="ECEEF2"/>
+                </a:solidFill>
+                <a:latin typeface="Courier New" pitchFamily="34" charset="0"/>
+                <a:ea typeface="Courier New" pitchFamily="34" charset="-122"/>
+                <a:cs typeface="Courier New" pitchFamily="34" charset="-120"/>
+              </a:rPr>
+              <a:t>        int r = 0, g = 0, b = 0;</a:t>
+            </a:r>
+            <a:pPr indent="0" marL="0">
+              <a:lnSpc>
+                <a:spcPct val="112000"/>
+              </a:lnSpc>
+              <a:buNone/>
+            </a:pPr>
+            <a:r>
+              <a:rPr lang="en-US" sz="920" dirty="0">
                 <a:solidFill>
                   <a:srgbClr val="000000"/>
                 </a:solidFill>
@@ -8186,92 +8309,24 @@
               <a:buNone/>
             </a:pPr>
             <a:r>
-              <a:rPr lang="en-US" sz="1050" dirty="0">
-                <a:solidFill>
-                  <a:srgbClr val="ECEEF2"/>
-                </a:solidFill>
-                <a:latin typeface="Courier New" pitchFamily="34" charset="0"/>
-                <a:ea typeface="Courier New" pitchFamily="34" charset="-122"/>
-                <a:cs typeface="Courier New" pitchFamily="34" charset="-120"/>
-              </a:rPr>
-              <a:t>    for (int dc = -</a:t>
-            </a:r>
-            <a:pPr indent="0" marL="0">
-              <a:lnSpc>
-                <a:spcPct val="112000"/>
-              </a:lnSpc>
-              <a:buNone/>
-            </a:pPr>
-            <a:r>
-              <a:rPr lang="en-US" sz="1050" dirty="0">
-                <a:solidFill>
-                  <a:srgbClr val="46D07E"/>
-                </a:solidFill>
-                <a:latin typeface="Courier New" pitchFamily="34" charset="0"/>
-                <a:ea typeface="Courier New" pitchFamily="34" charset="-122"/>
-                <a:cs typeface="Courier New" pitchFamily="34" charset="-120"/>
-              </a:rPr>
-              <a:t>BLUR_SIZE</a:t>
-            </a:r>
-            <a:pPr indent="0" marL="0">
-              <a:lnSpc>
-                <a:spcPct val="112000"/>
-              </a:lnSpc>
-              <a:buNone/>
-            </a:pPr>
-            <a:r>
-              <a:rPr lang="en-US" sz="1050" dirty="0">
-                <a:solidFill>
-                  <a:srgbClr val="ECEEF2"/>
-                </a:solidFill>
-                <a:latin typeface="Courier New" pitchFamily="34" charset="0"/>
-                <a:ea typeface="Courier New" pitchFamily="34" charset="-122"/>
-                <a:cs typeface="Courier New" pitchFamily="34" charset="-120"/>
-              </a:rPr>
-              <a:t>; dc &lt;= </a:t>
-            </a:r>
-            <a:pPr indent="0" marL="0">
-              <a:lnSpc>
-                <a:spcPct val="112000"/>
-              </a:lnSpc>
-              <a:buNone/>
-            </a:pPr>
-            <a:r>
-              <a:rPr lang="en-US" sz="1050" dirty="0">
-                <a:solidFill>
-                  <a:srgbClr val="46D07E"/>
-                </a:solidFill>
-                <a:latin typeface="Courier New" pitchFamily="34" charset="0"/>
-                <a:ea typeface="Courier New" pitchFamily="34" charset="-122"/>
-                <a:cs typeface="Courier New" pitchFamily="34" charset="-120"/>
-              </a:rPr>
-              <a:t>BLUR_SIZE</a:t>
-            </a:r>
-            <a:pPr indent="0" marL="0">
-              <a:lnSpc>
-                <a:spcPct val="112000"/>
-              </a:lnSpc>
-              <a:buNone/>
-            </a:pPr>
-            <a:r>
-              <a:rPr lang="en-US" sz="1050" dirty="0">
-                <a:solidFill>
-                  <a:srgbClr val="ECEEF2"/>
-                </a:solidFill>
-                <a:latin typeface="Courier New" pitchFamily="34" charset="0"/>
-                <a:ea typeface="Courier New" pitchFamily="34" charset="-122"/>
-                <a:cs typeface="Courier New" pitchFamily="34" charset="-120"/>
-              </a:rPr>
-              <a:t>; ++dc) {</a:t>
-            </a:r>
-            <a:pPr indent="0" marL="0">
-              <a:lnSpc>
-                <a:spcPct val="112000"/>
-              </a:lnSpc>
-              <a:buNone/>
-            </a:pPr>
-            <a:r>
-              <a:rPr lang="en-US" sz="1050" dirty="0">
+              <a:rPr lang="en-US" sz="920" dirty="0">
+                <a:solidFill>
+                  <a:srgbClr val="ECEEF2"/>
+                </a:solidFill>
+                <a:latin typeface="Courier New" pitchFamily="34" charset="0"/>
+                <a:ea typeface="Courier New" pitchFamily="34" charset="-122"/>
+                <a:cs typeface="Courier New" pitchFamily="34" charset="-120"/>
+              </a:rPr>
+              <a:t>        int n = 0;</a:t>
+            </a:r>
+            <a:pPr indent="0" marL="0">
+              <a:lnSpc>
+                <a:spcPct val="112000"/>
+              </a:lnSpc>
+              <a:buNone/>
+            </a:pPr>
+            <a:r>
+              <a:rPr lang="en-US" sz="920" dirty="0">
                 <a:solidFill>
                   <a:srgbClr val="000000"/>
                 </a:solidFill>
@@ -8289,24 +8344,92 @@
               <a:buNone/>
             </a:pPr>
             <a:r>
-              <a:rPr lang="en-US" sz="1050" dirty="0">
-                <a:solidFill>
-                  <a:srgbClr val="ECEEF2"/>
-                </a:solidFill>
-                <a:latin typeface="Courier New" pitchFamily="34" charset="0"/>
-                <a:ea typeface="Courier New" pitchFamily="34" charset="-122"/>
-                <a:cs typeface="Courier New" pitchFamily="34" charset="-120"/>
-              </a:rPr>
-              <a:t>        int nrow = row + dr;</a:t>
-            </a:r>
-            <a:pPr indent="0" marL="0">
-              <a:lnSpc>
-                <a:spcPct val="112000"/>
-              </a:lnSpc>
-              <a:buNone/>
-            </a:pPr>
-            <a:r>
-              <a:rPr lang="en-US" sz="1050" dirty="0">
+              <a:rPr lang="en-US" sz="920" dirty="0">
+                <a:solidFill>
+                  <a:srgbClr val="ECEEF2"/>
+                </a:solidFill>
+                <a:latin typeface="Courier New" pitchFamily="34" charset="0"/>
+                <a:ea typeface="Courier New" pitchFamily="34" charset="-122"/>
+                <a:cs typeface="Courier New" pitchFamily="34" charset="-120"/>
+              </a:rPr>
+              <a:t>        for (int dr = -</a:t>
+            </a:r>
+            <a:pPr indent="0" marL="0">
+              <a:lnSpc>
+                <a:spcPct val="112000"/>
+              </a:lnSpc>
+              <a:buNone/>
+            </a:pPr>
+            <a:r>
+              <a:rPr lang="en-US" sz="920" dirty="0">
+                <a:solidFill>
+                  <a:srgbClr val="46D07E"/>
+                </a:solidFill>
+                <a:latin typeface="Courier New" pitchFamily="34" charset="0"/>
+                <a:ea typeface="Courier New" pitchFamily="34" charset="-122"/>
+                <a:cs typeface="Courier New" pitchFamily="34" charset="-120"/>
+              </a:rPr>
+              <a:t>BLUR_SIZE</a:t>
+            </a:r>
+            <a:pPr indent="0" marL="0">
+              <a:lnSpc>
+                <a:spcPct val="112000"/>
+              </a:lnSpc>
+              <a:buNone/>
+            </a:pPr>
+            <a:r>
+              <a:rPr lang="en-US" sz="920" dirty="0">
+                <a:solidFill>
+                  <a:srgbClr val="ECEEF2"/>
+                </a:solidFill>
+                <a:latin typeface="Courier New" pitchFamily="34" charset="0"/>
+                <a:ea typeface="Courier New" pitchFamily="34" charset="-122"/>
+                <a:cs typeface="Courier New" pitchFamily="34" charset="-120"/>
+              </a:rPr>
+              <a:t>; dr &lt;= </a:t>
+            </a:r>
+            <a:pPr indent="0" marL="0">
+              <a:lnSpc>
+                <a:spcPct val="112000"/>
+              </a:lnSpc>
+              <a:buNone/>
+            </a:pPr>
+            <a:r>
+              <a:rPr lang="en-US" sz="920" dirty="0">
+                <a:solidFill>
+                  <a:srgbClr val="46D07E"/>
+                </a:solidFill>
+                <a:latin typeface="Courier New" pitchFamily="34" charset="0"/>
+                <a:ea typeface="Courier New" pitchFamily="34" charset="-122"/>
+                <a:cs typeface="Courier New" pitchFamily="34" charset="-120"/>
+              </a:rPr>
+              <a:t>BLUR_SIZE</a:t>
+            </a:r>
+            <a:pPr indent="0" marL="0">
+              <a:lnSpc>
+                <a:spcPct val="112000"/>
+              </a:lnSpc>
+              <a:buNone/>
+            </a:pPr>
+            <a:r>
+              <a:rPr lang="en-US" sz="920" dirty="0">
+                <a:solidFill>
+                  <a:srgbClr val="ECEEF2"/>
+                </a:solidFill>
+                <a:latin typeface="Courier New" pitchFamily="34" charset="0"/>
+                <a:ea typeface="Courier New" pitchFamily="34" charset="-122"/>
+                <a:cs typeface="Courier New" pitchFamily="34" charset="-120"/>
+              </a:rPr>
+              <a:t>; ++dr) {</a:t>
+            </a:r>
+            <a:pPr indent="0" marL="0">
+              <a:lnSpc>
+                <a:spcPct val="112000"/>
+              </a:lnSpc>
+              <a:buNone/>
+            </a:pPr>
+            <a:r>
+              <a:rPr lang="en-US" sz="920" dirty="0">
                 <a:solidFill>
                   <a:srgbClr val="000000"/>
                 </a:solidFill>
@@ -8324,24 +8447,92 @@
               <a:buNone/>
             </a:pPr>
             <a:r>
-              <a:rPr lang="en-US" sz="1050" dirty="0">
-                <a:solidFill>
-                  <a:srgbClr val="ECEEF2"/>
-                </a:solidFill>
-                <a:latin typeface="Courier New" pitchFamily="34" charset="0"/>
-                <a:ea typeface="Courier New" pitchFamily="34" charset="-122"/>
-                <a:cs typeface="Courier New" pitchFamily="34" charset="-120"/>
-              </a:rPr>
-              <a:t>        int ncol = col + dc;</a:t>
-            </a:r>
-            <a:pPr indent="0" marL="0">
-              <a:lnSpc>
-                <a:spcPct val="112000"/>
-              </a:lnSpc>
-              <a:buNone/>
-            </a:pPr>
-            <a:r>
-              <a:rPr lang="en-US" sz="1050" dirty="0">
+              <a:rPr lang="en-US" sz="920" dirty="0">
+                <a:solidFill>
+                  <a:srgbClr val="ECEEF2"/>
+                </a:solidFill>
+                <a:latin typeface="Courier New" pitchFamily="34" charset="0"/>
+                <a:ea typeface="Courier New" pitchFamily="34" charset="-122"/>
+                <a:cs typeface="Courier New" pitchFamily="34" charset="-120"/>
+              </a:rPr>
+              <a:t>            for (int dc = -</a:t>
+            </a:r>
+            <a:pPr indent="0" marL="0">
+              <a:lnSpc>
+                <a:spcPct val="112000"/>
+              </a:lnSpc>
+              <a:buNone/>
+            </a:pPr>
+            <a:r>
+              <a:rPr lang="en-US" sz="920" dirty="0">
+                <a:solidFill>
+                  <a:srgbClr val="46D07E"/>
+                </a:solidFill>
+                <a:latin typeface="Courier New" pitchFamily="34" charset="0"/>
+                <a:ea typeface="Courier New" pitchFamily="34" charset="-122"/>
+                <a:cs typeface="Courier New" pitchFamily="34" charset="-120"/>
+              </a:rPr>
+              <a:t>BLUR_SIZE</a:t>
+            </a:r>
+            <a:pPr indent="0" marL="0">
+              <a:lnSpc>
+                <a:spcPct val="112000"/>
+              </a:lnSpc>
+              <a:buNone/>
+            </a:pPr>
+            <a:r>
+              <a:rPr lang="en-US" sz="920" dirty="0">
+                <a:solidFill>
+                  <a:srgbClr val="ECEEF2"/>
+                </a:solidFill>
+                <a:latin typeface="Courier New" pitchFamily="34" charset="0"/>
+                <a:ea typeface="Courier New" pitchFamily="34" charset="-122"/>
+                <a:cs typeface="Courier New" pitchFamily="34" charset="-120"/>
+              </a:rPr>
+              <a:t>; dc &lt;= </a:t>
+            </a:r>
+            <a:pPr indent="0" marL="0">
+              <a:lnSpc>
+                <a:spcPct val="112000"/>
+              </a:lnSpc>
+              <a:buNone/>
+            </a:pPr>
+            <a:r>
+              <a:rPr lang="en-US" sz="920" dirty="0">
+                <a:solidFill>
+                  <a:srgbClr val="46D07E"/>
+                </a:solidFill>
+                <a:latin typeface="Courier New" pitchFamily="34" charset="0"/>
+                <a:ea typeface="Courier New" pitchFamily="34" charset="-122"/>
+                <a:cs typeface="Courier New" pitchFamily="34" charset="-120"/>
+              </a:rPr>
+              <a:t>BLUR_SIZE</a:t>
+            </a:r>
+            <a:pPr indent="0" marL="0">
+              <a:lnSpc>
+                <a:spcPct val="112000"/>
+              </a:lnSpc>
+              <a:buNone/>
+            </a:pPr>
+            <a:r>
+              <a:rPr lang="en-US" sz="920" dirty="0">
+                <a:solidFill>
+                  <a:srgbClr val="ECEEF2"/>
+                </a:solidFill>
+                <a:latin typeface="Courier New" pitchFamily="34" charset="0"/>
+                <a:ea typeface="Courier New" pitchFamily="34" charset="-122"/>
+                <a:cs typeface="Courier New" pitchFamily="34" charset="-120"/>
+              </a:rPr>
+              <a:t>; ++dc) {</a:t>
+            </a:r>
+            <a:pPr indent="0" marL="0">
+              <a:lnSpc>
+                <a:spcPct val="112000"/>
+              </a:lnSpc>
+              <a:buNone/>
+            </a:pPr>
+            <a:r>
+              <a:rPr lang="en-US" sz="920" dirty="0">
                 <a:solidFill>
                   <a:srgbClr val="000000"/>
                 </a:solidFill>
@@ -8359,24 +8550,24 @@
               <a:buNone/>
             </a:pPr>
             <a:r>
-              <a:rPr lang="en-US" sz="1050" dirty="0">
-                <a:solidFill>
-                  <a:srgbClr val="ECEEF2"/>
-                </a:solidFill>
-                <a:latin typeface="Courier New" pitchFamily="34" charset="0"/>
-                <a:ea typeface="Courier New" pitchFamily="34" charset="-122"/>
-                <a:cs typeface="Courier New" pitchFamily="34" charset="-120"/>
-              </a:rPr>
-              <a:t>        if (nrow &gt;= 0 &amp;&amp; nrow &lt; h &amp;&amp; ncol &gt;= 0 &amp;&amp; ncol &lt; w) {</a:t>
-            </a:r>
-            <a:pPr indent="0" marL="0">
-              <a:lnSpc>
-                <a:spcPct val="112000"/>
-              </a:lnSpc>
-              <a:buNone/>
-            </a:pPr>
-            <a:r>
-              <a:rPr lang="en-US" sz="1050" dirty="0">
+              <a:rPr lang="en-US" sz="920" dirty="0">
+                <a:solidFill>
+                  <a:srgbClr val="ECEEF2"/>
+                </a:solidFill>
+                <a:latin typeface="Courier New" pitchFamily="34" charset="0"/>
+                <a:ea typeface="Courier New" pitchFamily="34" charset="-122"/>
+                <a:cs typeface="Courier New" pitchFamily="34" charset="-120"/>
+              </a:rPr>
+              <a:t>                int nrow = row + dr;</a:t>
+            </a:r>
+            <a:pPr indent="0" marL="0">
+              <a:lnSpc>
+                <a:spcPct val="112000"/>
+              </a:lnSpc>
+              <a:buNone/>
+            </a:pPr>
+            <a:r>
+              <a:rPr lang="en-US" sz="920" dirty="0">
                 <a:solidFill>
                   <a:srgbClr val="000000"/>
                 </a:solidFill>
@@ -8394,24 +8585,24 @@
               <a:buNone/>
             </a:pPr>
             <a:r>
-              <a:rPr lang="en-US" sz="1050" dirty="0">
-                <a:solidFill>
-                  <a:srgbClr val="ECEEF2"/>
-                </a:solidFill>
-                <a:latin typeface="Courier New" pitchFamily="34" charset="0"/>
-                <a:ea typeface="Courier New" pitchFamily="34" charset="-122"/>
-                <a:cs typeface="Courier New" pitchFamily="34" charset="-120"/>
-              </a:rPr>
-              <a:t>            int i = (nrow * w + ncol) * 3;</a:t>
-            </a:r>
-            <a:pPr indent="0" marL="0">
-              <a:lnSpc>
-                <a:spcPct val="112000"/>
-              </a:lnSpc>
-              <a:buNone/>
-            </a:pPr>
-            <a:r>
-              <a:rPr lang="en-US" sz="1050" dirty="0">
+              <a:rPr lang="en-US" sz="920" dirty="0">
+                <a:solidFill>
+                  <a:srgbClr val="ECEEF2"/>
+                </a:solidFill>
+                <a:latin typeface="Courier New" pitchFamily="34" charset="0"/>
+                <a:ea typeface="Courier New" pitchFamily="34" charset="-122"/>
+                <a:cs typeface="Courier New" pitchFamily="34" charset="-120"/>
+              </a:rPr>
+              <a:t>                int ncol = col + dc;</a:t>
+            </a:r>
+            <a:pPr indent="0" marL="0">
+              <a:lnSpc>
+                <a:spcPct val="112000"/>
+              </a:lnSpc>
+              <a:buNone/>
+            </a:pPr>
+            <a:r>
+              <a:rPr lang="en-US" sz="920" dirty="0">
                 <a:solidFill>
                   <a:srgbClr val="000000"/>
                 </a:solidFill>
@@ -8429,24 +8620,24 @@
               <a:buNone/>
             </a:pPr>
             <a:r>
-              <a:rPr lang="en-US" sz="1050" dirty="0">
-                <a:solidFill>
-                  <a:srgbClr val="ECEEF2"/>
-                </a:solidFill>
-                <a:latin typeface="Courier New" pitchFamily="34" charset="0"/>
-                <a:ea typeface="Courier New" pitchFamily="34" charset="-122"/>
-                <a:cs typeface="Courier New" pitchFamily="34" charset="-120"/>
-              </a:rPr>
-              <a:t>            r += in[i + 0];</a:t>
-            </a:r>
-            <a:pPr indent="0" marL="0">
-              <a:lnSpc>
-                <a:spcPct val="112000"/>
-              </a:lnSpc>
-              <a:buNone/>
-            </a:pPr>
-            <a:r>
-              <a:rPr lang="en-US" sz="1050" dirty="0">
+              <a:rPr lang="en-US" sz="920" dirty="0">
+                <a:solidFill>
+                  <a:srgbClr val="ECEEF2"/>
+                </a:solidFill>
+                <a:latin typeface="Courier New" pitchFamily="34" charset="0"/>
+                <a:ea typeface="Courier New" pitchFamily="34" charset="-122"/>
+                <a:cs typeface="Courier New" pitchFamily="34" charset="-120"/>
+              </a:rPr>
+              <a:t>                if (nrow &gt;= 0 &amp;&amp; nrow &lt; h &amp;&amp; ncol &gt;= 0 &amp;&amp; ncol &lt; w) {</a:t>
+            </a:r>
+            <a:pPr indent="0" marL="0">
+              <a:lnSpc>
+                <a:spcPct val="112000"/>
+              </a:lnSpc>
+              <a:buNone/>
+            </a:pPr>
+            <a:r>
+              <a:rPr lang="en-US" sz="920" dirty="0">
                 <a:solidFill>
                   <a:srgbClr val="000000"/>
                 </a:solidFill>
@@ -8464,24 +8655,24 @@
               <a:buNone/>
             </a:pPr>
             <a:r>
-              <a:rPr lang="en-US" sz="1050" dirty="0">
-                <a:solidFill>
-                  <a:srgbClr val="ECEEF2"/>
-                </a:solidFill>
-                <a:latin typeface="Courier New" pitchFamily="34" charset="0"/>
-                <a:ea typeface="Courier New" pitchFamily="34" charset="-122"/>
-                <a:cs typeface="Courier New" pitchFamily="34" charset="-120"/>
-              </a:rPr>
-              <a:t>            g += in[i + 1];</a:t>
-            </a:r>
-            <a:pPr indent="0" marL="0">
-              <a:lnSpc>
-                <a:spcPct val="112000"/>
-              </a:lnSpc>
-              <a:buNone/>
-            </a:pPr>
-            <a:r>
-              <a:rPr lang="en-US" sz="1050" dirty="0">
+              <a:rPr lang="en-US" sz="920" dirty="0">
+                <a:solidFill>
+                  <a:srgbClr val="ECEEF2"/>
+                </a:solidFill>
+                <a:latin typeface="Courier New" pitchFamily="34" charset="0"/>
+                <a:ea typeface="Courier New" pitchFamily="34" charset="-122"/>
+                <a:cs typeface="Courier New" pitchFamily="34" charset="-120"/>
+              </a:rPr>
+              <a:t>                    int i = (nrow * w + ncol) * 3;</a:t>
+            </a:r>
+            <a:pPr indent="0" marL="0">
+              <a:lnSpc>
+                <a:spcPct val="112000"/>
+              </a:lnSpc>
+              <a:buNone/>
+            </a:pPr>
+            <a:r>
+              <a:rPr lang="en-US" sz="920" dirty="0">
                 <a:solidFill>
                   <a:srgbClr val="000000"/>
                 </a:solidFill>
@@ -8499,24 +8690,24 @@
               <a:buNone/>
             </a:pPr>
             <a:r>
-              <a:rPr lang="en-US" sz="1050" dirty="0">
-                <a:solidFill>
-                  <a:srgbClr val="ECEEF2"/>
-                </a:solidFill>
-                <a:latin typeface="Courier New" pitchFamily="34" charset="0"/>
-                <a:ea typeface="Courier New" pitchFamily="34" charset="-122"/>
-                <a:cs typeface="Courier New" pitchFamily="34" charset="-120"/>
-              </a:rPr>
-              <a:t>            b += in[i + 2];</a:t>
-            </a:r>
-            <a:pPr indent="0" marL="0">
-              <a:lnSpc>
-                <a:spcPct val="112000"/>
-              </a:lnSpc>
-              <a:buNone/>
-            </a:pPr>
-            <a:r>
-              <a:rPr lang="en-US" sz="1050" dirty="0">
+              <a:rPr lang="en-US" sz="920" dirty="0">
+                <a:solidFill>
+                  <a:srgbClr val="ECEEF2"/>
+                </a:solidFill>
+                <a:latin typeface="Courier New" pitchFamily="34" charset="0"/>
+                <a:ea typeface="Courier New" pitchFamily="34" charset="-122"/>
+                <a:cs typeface="Courier New" pitchFamily="34" charset="-120"/>
+              </a:rPr>
+              <a:t>                    r += in[i + 0];</a:t>
+            </a:r>
+            <a:pPr indent="0" marL="0">
+              <a:lnSpc>
+                <a:spcPct val="112000"/>
+              </a:lnSpc>
+              <a:buNone/>
+            </a:pPr>
+            <a:r>
+              <a:rPr lang="en-US" sz="920" dirty="0">
                 <a:solidFill>
                   <a:srgbClr val="000000"/>
                 </a:solidFill>
@@ -8534,24 +8725,24 @@
               <a:buNone/>
             </a:pPr>
             <a:r>
-              <a:rPr lang="en-US" sz="1050" dirty="0">
-                <a:solidFill>
-                  <a:srgbClr val="ECEEF2"/>
-                </a:solidFill>
-                <a:latin typeface="Courier New" pitchFamily="34" charset="0"/>
-                <a:ea typeface="Courier New" pitchFamily="34" charset="-122"/>
-                <a:cs typeface="Courier New" pitchFamily="34" charset="-120"/>
-              </a:rPr>
-              <a:t>            ++n;</a:t>
-            </a:r>
-            <a:pPr indent="0" marL="0">
-              <a:lnSpc>
-                <a:spcPct val="112000"/>
-              </a:lnSpc>
-              <a:buNone/>
-            </a:pPr>
-            <a:r>
-              <a:rPr lang="en-US" sz="1050" dirty="0">
+              <a:rPr lang="en-US" sz="920" dirty="0">
+                <a:solidFill>
+                  <a:srgbClr val="ECEEF2"/>
+                </a:solidFill>
+                <a:latin typeface="Courier New" pitchFamily="34" charset="0"/>
+                <a:ea typeface="Courier New" pitchFamily="34" charset="-122"/>
+                <a:cs typeface="Courier New" pitchFamily="34" charset="-120"/>
+              </a:rPr>
+              <a:t>                    g += in[i + 1];</a:t>
+            </a:r>
+            <a:pPr indent="0" marL="0">
+              <a:lnSpc>
+                <a:spcPct val="112000"/>
+              </a:lnSpc>
+              <a:buNone/>
+            </a:pPr>
+            <a:r>
+              <a:rPr lang="en-US" sz="920" dirty="0">
                 <a:solidFill>
                   <a:srgbClr val="000000"/>
                 </a:solidFill>
@@ -8569,24 +8760,24 @@
               <a:buNone/>
             </a:pPr>
             <a:r>
-              <a:rPr lang="en-US" sz="1050" dirty="0">
-                <a:solidFill>
-                  <a:srgbClr val="ECEEF2"/>
-                </a:solidFill>
-                <a:latin typeface="Courier New" pitchFamily="34" charset="0"/>
-                <a:ea typeface="Courier New" pitchFamily="34" charset="-122"/>
-                <a:cs typeface="Courier New" pitchFamily="34" charset="-120"/>
-              </a:rPr>
-              <a:t>        }</a:t>
-            </a:r>
-            <a:pPr indent="0" marL="0">
-              <a:lnSpc>
-                <a:spcPct val="112000"/>
-              </a:lnSpc>
-              <a:buNone/>
-            </a:pPr>
-            <a:r>
-              <a:rPr lang="en-US" sz="1050" dirty="0">
+              <a:rPr lang="en-US" sz="920" dirty="0">
+                <a:solidFill>
+                  <a:srgbClr val="ECEEF2"/>
+                </a:solidFill>
+                <a:latin typeface="Courier New" pitchFamily="34" charset="0"/>
+                <a:ea typeface="Courier New" pitchFamily="34" charset="-122"/>
+                <a:cs typeface="Courier New" pitchFamily="34" charset="-120"/>
+              </a:rPr>
+              <a:t>                    b += in[i + 2];</a:t>
+            </a:r>
+            <a:pPr indent="0" marL="0">
+              <a:lnSpc>
+                <a:spcPct val="112000"/>
+              </a:lnSpc>
+              <a:buNone/>
+            </a:pPr>
+            <a:r>
+              <a:rPr lang="en-US" sz="920" dirty="0">
                 <a:solidFill>
                   <a:srgbClr val="000000"/>
                 </a:solidFill>
@@ -8604,24 +8795,24 @@
               <a:buNone/>
             </a:pPr>
             <a:r>
-              <a:rPr lang="en-US" sz="1050" dirty="0">
-                <a:solidFill>
-                  <a:srgbClr val="ECEEF2"/>
-                </a:solidFill>
-                <a:latin typeface="Courier New" pitchFamily="34" charset="0"/>
-                <a:ea typeface="Courier New" pitchFamily="34" charset="-122"/>
-                <a:cs typeface="Courier New" pitchFamily="34" charset="-120"/>
-              </a:rPr>
-              <a:t>    }</a:t>
-            </a:r>
-            <a:pPr indent="0" marL="0">
-              <a:lnSpc>
-                <a:spcPct val="112000"/>
-              </a:lnSpc>
-              <a:buNone/>
-            </a:pPr>
-            <a:r>
-              <a:rPr lang="en-US" sz="1050" dirty="0">
+              <a:rPr lang="en-US" sz="920" dirty="0">
+                <a:solidFill>
+                  <a:srgbClr val="ECEEF2"/>
+                </a:solidFill>
+                <a:latin typeface="Courier New" pitchFamily="34" charset="0"/>
+                <a:ea typeface="Courier New" pitchFamily="34" charset="-122"/>
+                <a:cs typeface="Courier New" pitchFamily="34" charset="-120"/>
+              </a:rPr>
+              <a:t>                    ++n;</a:t>
+            </a:r>
+            <a:pPr indent="0" marL="0">
+              <a:lnSpc>
+                <a:spcPct val="112000"/>
+              </a:lnSpc>
+              <a:buNone/>
+            </a:pPr>
+            <a:r>
+              <a:rPr lang="en-US" sz="920" dirty="0">
                 <a:solidFill>
                   <a:srgbClr val="000000"/>
                 </a:solidFill>
@@ -8639,24 +8830,24 @@
               <a:buNone/>
             </a:pPr>
             <a:r>
-              <a:rPr lang="en-US" sz="1050" dirty="0">
-                <a:solidFill>
-                  <a:srgbClr val="ECEEF2"/>
-                </a:solidFill>
-                <a:latin typeface="Courier New" pitchFamily="34" charset="0"/>
-                <a:ea typeface="Courier New" pitchFamily="34" charset="-122"/>
-                <a:cs typeface="Courier New" pitchFamily="34" charset="-120"/>
-              </a:rPr>
-              <a:t>}</a:t>
-            </a:r>
-            <a:pPr indent="0" marL="0">
-              <a:lnSpc>
-                <a:spcPct val="112000"/>
-              </a:lnSpc>
-              <a:buNone/>
-            </a:pPr>
-            <a:r>
-              <a:rPr lang="en-US" sz="1050" dirty="0">
+              <a:rPr lang="en-US" sz="920" dirty="0">
+                <a:solidFill>
+                  <a:srgbClr val="ECEEF2"/>
+                </a:solidFill>
+                <a:latin typeface="Courier New" pitchFamily="34" charset="0"/>
+                <a:ea typeface="Courier New" pitchFamily="34" charset="-122"/>
+                <a:cs typeface="Courier New" pitchFamily="34" charset="-120"/>
+              </a:rPr>
+              <a:t>                }</a:t>
+            </a:r>
+            <a:pPr indent="0" marL="0">
+              <a:lnSpc>
+                <a:spcPct val="112000"/>
+              </a:lnSpc>
+              <a:buNone/>
+            </a:pPr>
+            <a:r>
+              <a:rPr lang="en-US" sz="920" dirty="0">
                 <a:solidFill>
                   <a:srgbClr val="000000"/>
                 </a:solidFill>
@@ -8674,24 +8865,24 @@
               <a:buNone/>
             </a:pPr>
             <a:r>
-              <a:rPr lang="en-US" sz="1050" dirty="0">
-                <a:solidFill>
-                  <a:srgbClr val="ECEEF2"/>
-                </a:solidFill>
-                <a:latin typeface="Courier New" pitchFamily="34" charset="0"/>
-                <a:ea typeface="Courier New" pitchFamily="34" charset="-122"/>
-                <a:cs typeface="Courier New" pitchFamily="34" charset="-120"/>
-              </a:rPr>
-              <a:t>int o = (row * w + col) * 3;</a:t>
-            </a:r>
-            <a:pPr indent="0" marL="0">
-              <a:lnSpc>
-                <a:spcPct val="112000"/>
-              </a:lnSpc>
-              <a:buNone/>
-            </a:pPr>
-            <a:r>
-              <a:rPr lang="en-US" sz="1050" dirty="0">
+              <a:rPr lang="en-US" sz="920" dirty="0">
+                <a:solidFill>
+                  <a:srgbClr val="ECEEF2"/>
+                </a:solidFill>
+                <a:latin typeface="Courier New" pitchFamily="34" charset="0"/>
+                <a:ea typeface="Courier New" pitchFamily="34" charset="-122"/>
+                <a:cs typeface="Courier New" pitchFamily="34" charset="-120"/>
+              </a:rPr>
+              <a:t>            }</a:t>
+            </a:r>
+            <a:pPr indent="0" marL="0">
+              <a:lnSpc>
+                <a:spcPct val="112000"/>
+              </a:lnSpc>
+              <a:buNone/>
+            </a:pPr>
+            <a:r>
+              <a:rPr lang="en-US" sz="920" dirty="0">
                 <a:solidFill>
                   <a:srgbClr val="000000"/>
                 </a:solidFill>
@@ -8709,24 +8900,24 @@
               <a:buNone/>
             </a:pPr>
             <a:r>
-              <a:rPr lang="en-US" sz="1050" dirty="0">
-                <a:solidFill>
-                  <a:srgbClr val="ECEEF2"/>
-                </a:solidFill>
-                <a:latin typeface="Courier New" pitchFamily="34" charset="0"/>
-                <a:ea typeface="Courier New" pitchFamily="34" charset="-122"/>
-                <a:cs typeface="Courier New" pitchFamily="34" charset="-120"/>
-              </a:rPr>
-              <a:t>out[o + 0] = (unsigned char)((float)r / n);</a:t>
-            </a:r>
-            <a:pPr indent="0" marL="0">
-              <a:lnSpc>
-                <a:spcPct val="112000"/>
-              </a:lnSpc>
-              <a:buNone/>
-            </a:pPr>
-            <a:r>
-              <a:rPr lang="en-US" sz="1050" dirty="0">
+              <a:rPr lang="en-US" sz="920" dirty="0">
+                <a:solidFill>
+                  <a:srgbClr val="ECEEF2"/>
+                </a:solidFill>
+                <a:latin typeface="Courier New" pitchFamily="34" charset="0"/>
+                <a:ea typeface="Courier New" pitchFamily="34" charset="-122"/>
+                <a:cs typeface="Courier New" pitchFamily="34" charset="-120"/>
+              </a:rPr>
+              <a:t>        }</a:t>
+            </a:r>
+            <a:pPr indent="0" marL="0">
+              <a:lnSpc>
+                <a:spcPct val="112000"/>
+              </a:lnSpc>
+              <a:buNone/>
+            </a:pPr>
+            <a:r>
+              <a:rPr lang="en-US" sz="920" dirty="0">
                 <a:solidFill>
                   <a:srgbClr val="000000"/>
                 </a:solidFill>
@@ -8744,24 +8935,24 @@
               <a:buNone/>
             </a:pPr>
             <a:r>
-              <a:rPr lang="en-US" sz="1050" dirty="0">
-                <a:solidFill>
-                  <a:srgbClr val="ECEEF2"/>
-                </a:solidFill>
-                <a:latin typeface="Courier New" pitchFamily="34" charset="0"/>
-                <a:ea typeface="Courier New" pitchFamily="34" charset="-122"/>
-                <a:cs typeface="Courier New" pitchFamily="34" charset="-120"/>
-              </a:rPr>
-              <a:t>out[o + 1] = (unsigned char)((float)g / n);</a:t>
-            </a:r>
-            <a:pPr indent="0" marL="0">
-              <a:lnSpc>
-                <a:spcPct val="112000"/>
-              </a:lnSpc>
-              <a:buNone/>
-            </a:pPr>
-            <a:r>
-              <a:rPr lang="en-US" sz="1050" dirty="0">
+              <a:rPr lang="en-US" sz="920" dirty="0">
+                <a:solidFill>
+                  <a:srgbClr val="ECEEF2"/>
+                </a:solidFill>
+                <a:latin typeface="Courier New" pitchFamily="34" charset="0"/>
+                <a:ea typeface="Courier New" pitchFamily="34" charset="-122"/>
+                <a:cs typeface="Courier New" pitchFamily="34" charset="-120"/>
+              </a:rPr>
+              <a:t>        int o = (row * w + col) * 3;</a:t>
+            </a:r>
+            <a:pPr indent="0" marL="0">
+              <a:lnSpc>
+                <a:spcPct val="112000"/>
+              </a:lnSpc>
+              <a:buNone/>
+            </a:pPr>
+            <a:r>
+              <a:rPr lang="en-US" sz="920" dirty="0">
                 <a:solidFill>
                   <a:srgbClr val="000000"/>
                 </a:solidFill>
@@ -8779,17 +8970,157 @@
               <a:buNone/>
             </a:pPr>
             <a:r>
-              <a:rPr lang="en-US" sz="1050" dirty="0">
-                <a:solidFill>
-                  <a:srgbClr val="ECEEF2"/>
-                </a:solidFill>
-                <a:latin typeface="Courier New" pitchFamily="34" charset="0"/>
-                <a:ea typeface="Courier New" pitchFamily="34" charset="-122"/>
-                <a:cs typeface="Courier New" pitchFamily="34" charset="-120"/>
-              </a:rPr>
-              <a:t>out[o + 2] = (unsigned char)((float)b / n);</a:t>
-            </a:r>
-            <a:endParaRPr lang="en-US" sz="1050" dirty="0"/>
+              <a:rPr lang="en-US" sz="920" dirty="0">
+                <a:solidFill>
+                  <a:srgbClr val="ECEEF2"/>
+                </a:solidFill>
+                <a:latin typeface="Courier New" pitchFamily="34" charset="0"/>
+                <a:ea typeface="Courier New" pitchFamily="34" charset="-122"/>
+                <a:cs typeface="Courier New" pitchFamily="34" charset="-120"/>
+              </a:rPr>
+              <a:t>        out[o + 0] = (unsigned char)((float)r / n);</a:t>
+            </a:r>
+            <a:pPr indent="0" marL="0">
+              <a:lnSpc>
+                <a:spcPct val="112000"/>
+              </a:lnSpc>
+              <a:buNone/>
+            </a:pPr>
+            <a:r>
+              <a:rPr lang="en-US" sz="920" dirty="0">
+                <a:solidFill>
+                  <a:srgbClr val="000000"/>
+                </a:solidFill>
+                <a:latin typeface="Courier New" pitchFamily="34" charset="0"/>
+                <a:ea typeface="Courier New" pitchFamily="34" charset="-122"/>
+                <a:cs typeface="Courier New" pitchFamily="34" charset="-120"/>
+              </a:rPr>
+              <a:t>
+</a:t>
+            </a:r>
+            <a:pPr indent="0" marL="0">
+              <a:lnSpc>
+                <a:spcPct val="112000"/>
+              </a:lnSpc>
+              <a:buNone/>
+            </a:pPr>
+            <a:r>
+              <a:rPr lang="en-US" sz="920" dirty="0">
+                <a:solidFill>
+                  <a:srgbClr val="ECEEF2"/>
+                </a:solidFill>
+                <a:latin typeface="Courier New" pitchFamily="34" charset="0"/>
+                <a:ea typeface="Courier New" pitchFamily="34" charset="-122"/>
+                <a:cs typeface="Courier New" pitchFamily="34" charset="-120"/>
+              </a:rPr>
+              <a:t>        out[o + 1] = (unsigned char)((float)g / n);</a:t>
+            </a:r>
+            <a:pPr indent="0" marL="0">
+              <a:lnSpc>
+                <a:spcPct val="112000"/>
+              </a:lnSpc>
+              <a:buNone/>
+            </a:pPr>
+            <a:r>
+              <a:rPr lang="en-US" sz="920" dirty="0">
+                <a:solidFill>
+                  <a:srgbClr val="000000"/>
+                </a:solidFill>
+                <a:latin typeface="Courier New" pitchFamily="34" charset="0"/>
+                <a:ea typeface="Courier New" pitchFamily="34" charset="-122"/>
+                <a:cs typeface="Courier New" pitchFamily="34" charset="-120"/>
+              </a:rPr>
+              <a:t>
+</a:t>
+            </a:r>
+            <a:pPr indent="0" marL="0">
+              <a:lnSpc>
+                <a:spcPct val="112000"/>
+              </a:lnSpc>
+              <a:buNone/>
+            </a:pPr>
+            <a:r>
+              <a:rPr lang="en-US" sz="920" dirty="0">
+                <a:solidFill>
+                  <a:srgbClr val="ECEEF2"/>
+                </a:solidFill>
+                <a:latin typeface="Courier New" pitchFamily="34" charset="0"/>
+                <a:ea typeface="Courier New" pitchFamily="34" charset="-122"/>
+                <a:cs typeface="Courier New" pitchFamily="34" charset="-120"/>
+              </a:rPr>
+              <a:t>        out[o + 2] = (unsigned char)((float)b / n);</a:t>
+            </a:r>
+            <a:pPr indent="0" marL="0">
+              <a:lnSpc>
+                <a:spcPct val="112000"/>
+              </a:lnSpc>
+              <a:buNone/>
+            </a:pPr>
+            <a:r>
+              <a:rPr lang="en-US" sz="920" dirty="0">
+                <a:solidFill>
+                  <a:srgbClr val="000000"/>
+                </a:solidFill>
+                <a:latin typeface="Courier New" pitchFamily="34" charset="0"/>
+                <a:ea typeface="Courier New" pitchFamily="34" charset="-122"/>
+                <a:cs typeface="Courier New" pitchFamily="34" charset="-120"/>
+              </a:rPr>
+              <a:t>
+</a:t>
+            </a:r>
+            <a:pPr indent="0" marL="0">
+              <a:lnSpc>
+                <a:spcPct val="112000"/>
+              </a:lnSpc>
+              <a:buNone/>
+            </a:pPr>
+            <a:r>
+              <a:rPr lang="en-US" sz="920" dirty="0">
+                <a:solidFill>
+                  <a:srgbClr val="ECEEF2"/>
+                </a:solidFill>
+                <a:latin typeface="Courier New" pitchFamily="34" charset="0"/>
+                <a:ea typeface="Courier New" pitchFamily="34" charset="-122"/>
+                <a:cs typeface="Courier New" pitchFamily="34" charset="-120"/>
+              </a:rPr>
+              <a:t>    }</a:t>
+            </a:r>
+            <a:pPr indent="0" marL="0">
+              <a:lnSpc>
+                <a:spcPct val="112000"/>
+              </a:lnSpc>
+              <a:buNone/>
+            </a:pPr>
+            <a:r>
+              <a:rPr lang="en-US" sz="920" dirty="0">
+                <a:solidFill>
+                  <a:srgbClr val="000000"/>
+                </a:solidFill>
+                <a:latin typeface="Courier New" pitchFamily="34" charset="0"/>
+                <a:ea typeface="Courier New" pitchFamily="34" charset="-122"/>
+                <a:cs typeface="Courier New" pitchFamily="34" charset="-120"/>
+              </a:rPr>
+              <a:t>
+</a:t>
+            </a:r>
+            <a:pPr indent="0" marL="0">
+              <a:lnSpc>
+                <a:spcPct val="112000"/>
+              </a:lnSpc>
+              <a:buNone/>
+            </a:pPr>
+            <a:r>
+              <a:rPr lang="en-US" sz="920" dirty="0">
+                <a:solidFill>
+                  <a:srgbClr val="ECEEF2"/>
+                </a:solidFill>
+                <a:latin typeface="Courier New" pitchFamily="34" charset="0"/>
+                <a:ea typeface="Courier New" pitchFamily="34" charset="-122"/>
+                <a:cs typeface="Courier New" pitchFamily="34" charset="-120"/>
+              </a:rPr>
+              <a:t>}</a:t>
+            </a:r>
+            <a:endParaRPr lang="en-US" sz="920" dirty="0"/>
           </a:p>
         </p:txBody>
       </p:sp>
@@ -8801,8 +9132,8 @@
         </p:nvSpPr>
         <p:spPr>
           <a:xfrm>
-            <a:off x="8275320" y="1783080"/>
-            <a:ext cx="3139135" cy="3977640"/>
+            <a:off x="8549640" y="1783080"/>
+            <a:ext cx="2864815" cy="4114800"/>
           </a:xfrm>
           <a:prstGeom prst="rect">
             <a:avLst/>
@@ -8826,8 +9157,8 @@
         </p:nvSpPr>
         <p:spPr>
           <a:xfrm>
-            <a:off x="8531352" y="1984248"/>
-            <a:ext cx="2681935" cy="274320"/>
+            <a:off x="8805672" y="1984248"/>
+            <a:ext cx="2407615" cy="274320"/>
           </a:xfrm>
           <a:prstGeom prst="rect">
             <a:avLst/>
@@ -8865,8 +9196,8 @@
         </p:nvSpPr>
         <p:spPr>
           <a:xfrm>
-            <a:off x="8531352" y="2331720"/>
-            <a:ext cx="2681935" cy="3246120"/>
+            <a:off x="8805672" y="2331720"/>
+            <a:ext cx="2407615" cy="3383280"/>
           </a:xfrm>
           <a:prstGeom prst="rect">
             <a:avLst/>
@@ -8888,7 +9219,7 @@
               <a:buNone/>
             </a:pPr>
             <a:r>
-              <a:rPr lang="en-US" sz="1300" dirty="0">
+              <a:rPr lang="en-US" sz="1250" dirty="0">
                 <a:solidFill>
                   <a:srgbClr val="ECEEF2"/>
                 </a:solidFill>
@@ -8896,9 +9227,9 @@
                 <a:ea typeface="Arial" pitchFamily="34" charset="-122"/>
                 <a:cs typeface="Arial" pitchFamily="34" charset="-120"/>
               </a:rPr>
-              <a:t>Add the #define at the top.</a:t>
-            </a:r>
-            <a:endParaRPr lang="en-US" sz="1300" dirty="0"/>
+              <a:t>student/blur.cu — main() is already there. This goes above it.</a:t>
+            </a:r>
+            <a:endParaRPr lang="en-US" sz="1250" dirty="0"/>
           </a:p>
           <a:p>
             <a:pPr indent="0" marL="0">
@@ -8911,7 +9242,7 @@
               <a:buNone/>
             </a:pPr>
             <a:r>
-              <a:rPr lang="en-US" sz="1300" dirty="0">
+              <a:rPr lang="en-US" sz="1250" dirty="0">
                 <a:solidFill>
                   <a:srgbClr val="ECEEF2"/>
                 </a:solidFill>
@@ -8919,9 +9250,9 @@
                 <a:ea typeface="Arial" pitchFamily="34" charset="-122"/>
                 <a:cs typeface="Arial" pitchFamily="34" charset="-120"/>
               </a:rPr>
-              <a:t>col, row and the if are already there — leave them.</a:t>
-            </a:r>
-            <a:endParaRPr lang="en-US" sz="1300" dirty="0"/>
+              <a:t>col, row, the if — same start as greyscale.</a:t>
+            </a:r>
+            <a:endParaRPr lang="en-US" sz="1250" dirty="0"/>
           </a:p>
           <a:p>
             <a:pPr indent="0" marL="0">
@@ -8934,7 +9265,7 @@
               <a:buNone/>
             </a:pPr>
             <a:r>
-              <a:rPr lang="en-US" sz="1300" dirty="0">
+              <a:rPr lang="en-US" sz="1250" dirty="0">
                 <a:solidFill>
                   <a:srgbClr val="ECEEF2"/>
                 </a:solidFill>
@@ -8942,9 +9273,9 @@
                 <a:ea typeface="Arial" pitchFamily="34" charset="-122"/>
                 <a:cs typeface="Arial" pitchFamily="34" charset="-120"/>
               </a:rPr>
-              <a:t>Walk the square around me. Skip neighbours that fall off the picture. Count the ones I used.</a:t>
-            </a:r>
-            <a:endParaRPr lang="en-US" sz="1300" dirty="0"/>
+              <a:t>Walk the square around me. Skip neighbours off the picture. Count the ones I used.</a:t>
+            </a:r>
+            <a:endParaRPr lang="en-US" sz="1250" dirty="0"/>
           </a:p>
           <a:p>
             <a:pPr indent="0" marL="0">
@@ -8957,7 +9288,7 @@
               <a:buNone/>
             </a:pPr>
             <a:r>
-              <a:rPr lang="en-US" sz="1300" dirty="0">
+              <a:rPr lang="en-US" sz="1250" dirty="0">
                 <a:solidFill>
                   <a:srgbClr val="ECEEF2"/>
                 </a:solidFill>
@@ -8967,30 +9298,7 @@
               </a:rPr>
               <a:t>Divide by n — what I counted — not by 49.</a:t>
             </a:r>
-            <a:endParaRPr lang="en-US" sz="1300" dirty="0"/>
-          </a:p>
-          <a:p>
-            <a:pPr indent="0" marL="0">
-              <a:lnSpc>
-                <a:spcPct val="115000"/>
-              </a:lnSpc>
-              <a:spcAft>
-                <a:spcPts val="500"/>
-              </a:spcAft>
-              <a:buNone/>
-            </a:pPr>
-            <a:r>
-              <a:rPr lang="en-US" sz="1300" dirty="0">
-                <a:solidFill>
-                  <a:srgbClr val="ECEEF2"/>
-                </a:solidFill>
-                <a:latin typeface="Arial" pitchFamily="34" charset="0"/>
-                <a:ea typeface="Arial" pitchFamily="34" charset="-122"/>
-                <a:cs typeface="Arial" pitchFamily="34" charset="-120"/>
-              </a:rPr>
-              <a:t>Every CUDA call in main(): untouched.</a:t>
-            </a:r>
-            <a:endParaRPr lang="en-US" sz="1300" dirty="0"/>
+            <a:endParaRPr lang="en-US" sz="1250" dirty="0"/>
           </a:p>
         </p:txBody>
       </p:sp>
@@ -9002,7 +9310,7 @@
         </p:nvSpPr>
         <p:spPr>
           <a:xfrm>
-            <a:off x="777240" y="5943600"/>
+            <a:off x="777240" y="6035040"/>
             <a:ext cx="10637215" cy="566928"/>
           </a:xfrm>
           <a:prstGeom prst="rect">
@@ -9027,7 +9335,7 @@
         </p:nvSpPr>
         <p:spPr>
           <a:xfrm>
-            <a:off x="1051560" y="5943600"/>
+            <a:off x="1051560" y="6035040"/>
             <a:ext cx="10180015" cy="566928"/>
           </a:xfrm>
           <a:prstGeom prst="rect">
@@ -9052,7 +9360,7 @@
                 <a:ea typeface="Arial" pitchFamily="34" charset="-122"/>
                 <a:cs typeface="Arial" pitchFamily="34" charset="-120"/>
               </a:rPr>
-              <a:t>✓  Run the cell, then lab.run().  Expect: ✅ Blur, edges included — then lab.show().</a:t>
+              <a:t>✓  Run the cell, then lab.run("blur").  Expect: ✅ Blur, edges included — then lab.show().</a:t>
             </a:r>
             <a:endParaRPr lang="en-US" sz="1500" dirty="0"/>
           </a:p>
@@ -9066,8 +9374,8 @@
         </p:nvSpPr>
         <p:spPr>
           <a:xfrm>
-            <a:off x="5928055" y="6556248"/>
-            <a:ext cx="5486400" cy="228600"/>
+            <a:off x="5928055" y="6620256"/>
+            <a:ext cx="5486400" cy="201168"/>
           </a:xfrm>
           <a:prstGeom prst="rect">
             <a:avLst/>

</xml_diff>